<commit_message>
Day 9 Agenda and slide updates
</commit_message>
<xml_diff>
--- a/docs/slides/DMIT2008-Week5-Day1-newest-React-effect-state-jsx-conditionals.pptx
+++ b/docs/slides/DMIT2008-Week5-Day1-newest-React-effect-state-jsx-conditionals.pptx
@@ -275,149 +275,12 @@
       </a:defRPr>
     </a:lvl9pPr>
   </p:defaultTextStyle>
+  <p:extLst>
+    <p:ext uri="{EFAFB233-063F-42B5-8137-9DF3F51BA10A}">
+      <p15:sldGuideLst xmlns:p15="http://schemas.microsoft.com/office/powerpoint/2012/main"/>
+    </p:ext>
+  </p:extLst>
 </p:presentation>
-</file>
-
-<file path=ppt/changesInfos/changesInfo1.xml><?xml version="1.0" encoding="utf-8"?>
-<pc:chgInfo xmlns:a="http://schemas.openxmlformats.org/drawingml/2006/main" xmlns:r="http://schemas.openxmlformats.org/officeDocument/2006/relationships" xmlns:ac="http://schemas.microsoft.com/office/drawing/2013/main/command" xmlns:pc="http://schemas.microsoft.com/office/powerpoint/2013/main/command">
-  <pc:docChgLst>
-    <pc:chgData name="Jhimlie Eustaquio" userId="056709674e28ecbe" providerId="LiveId" clId="{EE34A1E4-FB65-4281-8752-43B6C66EB902}"/>
-    <pc:docChg chg="undo custSel modSld">
-      <pc:chgData name="Jhimlie Eustaquio" userId="056709674e28ecbe" providerId="LiveId" clId="{EE34A1E4-FB65-4281-8752-43B6C66EB902}" dt="2026-10-03T22:02:50.314" v="639" actId="20577"/>
-      <pc:docMkLst>
-        <pc:docMk/>
-      </pc:docMkLst>
-      <pc:sldChg chg="modSp modNotes">
-        <pc:chgData name="Jhimlie Eustaquio" userId="056709674e28ecbe" providerId="LiveId" clId="{EE34A1E4-FB65-4281-8752-43B6C66EB902}" dt="2026-10-02T20:35:30.532" v="0"/>
-        <pc:sldMkLst>
-          <pc:docMk/>
-          <pc:sldMk cId="0" sldId="259"/>
-        </pc:sldMkLst>
-        <pc:spChg chg="mod">
-          <ac:chgData name="Jhimlie Eustaquio" userId="056709674e28ecbe" providerId="LiveId" clId="{EE34A1E4-FB65-4281-8752-43B6C66EB902}" dt="2026-10-02T20:35:30.532" v="0"/>
-          <ac:spMkLst>
-            <pc:docMk/>
-            <pc:sldMk cId="0" sldId="259"/>
-            <ac:spMk id="81" creationId="{00000000-0000-0000-0000-000000000000}"/>
-          </ac:spMkLst>
-        </pc:spChg>
-      </pc:sldChg>
-      <pc:sldChg chg="modSp mod">
-        <pc:chgData name="Jhimlie Eustaquio" userId="056709674e28ecbe" providerId="LiveId" clId="{EE34A1E4-FB65-4281-8752-43B6C66EB902}" dt="2026-10-02T23:49:15.713" v="43" actId="20577"/>
-        <pc:sldMkLst>
-          <pc:docMk/>
-          <pc:sldMk cId="0" sldId="260"/>
-        </pc:sldMkLst>
-        <pc:spChg chg="mod">
-          <ac:chgData name="Jhimlie Eustaquio" userId="056709674e28ecbe" providerId="LiveId" clId="{EE34A1E4-FB65-4281-8752-43B6C66EB902}" dt="2026-10-02T23:49:15.713" v="43" actId="20577"/>
-          <ac:spMkLst>
-            <pc:docMk/>
-            <pc:sldMk cId="0" sldId="260"/>
-            <ac:spMk id="87" creationId="{00000000-0000-0000-0000-000000000000}"/>
-          </ac:spMkLst>
-        </pc:spChg>
-      </pc:sldChg>
-      <pc:sldChg chg="modSp mod modNotes">
-        <pc:chgData name="Jhimlie Eustaquio" userId="056709674e28ecbe" providerId="LiveId" clId="{EE34A1E4-FB65-4281-8752-43B6C66EB902}" dt="2026-10-02T23:48:43.799" v="42"/>
-        <pc:sldMkLst>
-          <pc:docMk/>
-          <pc:sldMk cId="0" sldId="261"/>
-        </pc:sldMkLst>
-        <pc:spChg chg="mod">
-          <ac:chgData name="Jhimlie Eustaquio" userId="056709674e28ecbe" providerId="LiveId" clId="{EE34A1E4-FB65-4281-8752-43B6C66EB902}" dt="2026-10-02T23:48:43.799" v="42"/>
-          <ac:spMkLst>
-            <pc:docMk/>
-            <pc:sldMk cId="0" sldId="261"/>
-            <ac:spMk id="97" creationId="{00000000-0000-0000-0000-000000000000}"/>
-          </ac:spMkLst>
-        </pc:spChg>
-      </pc:sldChg>
-      <pc:sldChg chg="modNotesTx">
-        <pc:chgData name="Jhimlie Eustaquio" userId="056709674e28ecbe" providerId="LiveId" clId="{EE34A1E4-FB65-4281-8752-43B6C66EB902}" dt="2026-10-03T22:02:50.314" v="639" actId="20577"/>
-        <pc:sldMkLst>
-          <pc:docMk/>
-          <pc:sldMk cId="0" sldId="263"/>
-        </pc:sldMkLst>
-      </pc:sldChg>
-      <pc:sldChg chg="modSp mod modNotes modNotesTx">
-        <pc:chgData name="Jhimlie Eustaquio" userId="056709674e28ecbe" providerId="LiveId" clId="{EE34A1E4-FB65-4281-8752-43B6C66EB902}" dt="2026-10-03T00:29:17.013" v="566" actId="20577"/>
-        <pc:sldMkLst>
-          <pc:docMk/>
-          <pc:sldMk cId="0" sldId="264"/>
-        </pc:sldMkLst>
-        <pc:spChg chg="mod">
-          <ac:chgData name="Jhimlie Eustaquio" userId="056709674e28ecbe" providerId="LiveId" clId="{EE34A1E4-FB65-4281-8752-43B6C66EB902}" dt="2026-10-03T00:03:10.720" v="203" actId="20577"/>
-          <ac:spMkLst>
-            <pc:docMk/>
-            <pc:sldMk cId="0" sldId="264"/>
-            <ac:spMk id="119" creationId="{00000000-0000-0000-0000-000000000000}"/>
-          </ac:spMkLst>
-        </pc:spChg>
-      </pc:sldChg>
-      <pc:sldChg chg="modSp mod">
-        <pc:chgData name="Jhimlie Eustaquio" userId="056709674e28ecbe" providerId="LiveId" clId="{EE34A1E4-FB65-4281-8752-43B6C66EB902}" dt="2026-10-03T00:48:35.237" v="608" actId="20577"/>
-        <pc:sldMkLst>
-          <pc:docMk/>
-          <pc:sldMk cId="0" sldId="265"/>
-        </pc:sldMkLst>
-        <pc:spChg chg="mod">
-          <ac:chgData name="Jhimlie Eustaquio" userId="056709674e28ecbe" providerId="LiveId" clId="{EE34A1E4-FB65-4281-8752-43B6C66EB902}" dt="2026-10-03T00:48:35.237" v="608" actId="20577"/>
-          <ac:spMkLst>
-            <pc:docMk/>
-            <pc:sldMk cId="0" sldId="265"/>
-            <ac:spMk id="126" creationId="{00000000-0000-0000-0000-000000000000}"/>
-          </ac:spMkLst>
-        </pc:spChg>
-        <pc:spChg chg="mod">
-          <ac:chgData name="Jhimlie Eustaquio" userId="056709674e28ecbe" providerId="LiveId" clId="{EE34A1E4-FB65-4281-8752-43B6C66EB902}" dt="2026-10-03T00:21:08.932" v="554" actId="20577"/>
-          <ac:spMkLst>
-            <pc:docMk/>
-            <pc:sldMk cId="0" sldId="265"/>
-            <ac:spMk id="127" creationId="{00000000-0000-0000-0000-000000000000}"/>
-          </ac:spMkLst>
-        </pc:spChg>
-      </pc:sldChg>
-      <pc:sldChg chg="modSp mod">
-        <pc:chgData name="Jhimlie Eustaquio" userId="056709674e28ecbe" providerId="LiveId" clId="{EE34A1E4-FB65-4281-8752-43B6C66EB902}" dt="2026-10-03T21:25:52.523" v="627" actId="20577"/>
-        <pc:sldMkLst>
-          <pc:docMk/>
-          <pc:sldMk cId="0" sldId="266"/>
-        </pc:sldMkLst>
-        <pc:spChg chg="mod">
-          <ac:chgData name="Jhimlie Eustaquio" userId="056709674e28ecbe" providerId="LiveId" clId="{EE34A1E4-FB65-4281-8752-43B6C66EB902}" dt="2026-10-03T21:25:52.523" v="627" actId="20577"/>
-          <ac:spMkLst>
-            <pc:docMk/>
-            <pc:sldMk cId="0" sldId="266"/>
-            <ac:spMk id="133" creationId="{00000000-0000-0000-0000-000000000000}"/>
-          </ac:spMkLst>
-        </pc:spChg>
-      </pc:sldChg>
-      <pc:sldChg chg="modSp mod">
-        <pc:chgData name="Jhimlie Eustaquio" userId="056709674e28ecbe" providerId="LiveId" clId="{EE34A1E4-FB65-4281-8752-43B6C66EB902}" dt="2026-10-03T21:38:57.893" v="630" actId="20577"/>
-        <pc:sldMkLst>
-          <pc:docMk/>
-          <pc:sldMk cId="0" sldId="267"/>
-        </pc:sldMkLst>
-        <pc:spChg chg="mod">
-          <ac:chgData name="Jhimlie Eustaquio" userId="056709674e28ecbe" providerId="LiveId" clId="{EE34A1E4-FB65-4281-8752-43B6C66EB902}" dt="2026-10-03T21:38:57.893" v="630" actId="20577"/>
-          <ac:spMkLst>
-            <pc:docMk/>
-            <pc:sldMk cId="0" sldId="267"/>
-            <ac:spMk id="142" creationId="{00000000-0000-0000-0000-000000000000}"/>
-          </ac:spMkLst>
-        </pc:spChg>
-        <pc:spChg chg="mod">
-          <ac:chgData name="Jhimlie Eustaquio" userId="056709674e28ecbe" providerId="LiveId" clId="{EE34A1E4-FB65-4281-8752-43B6C66EB902}" dt="2026-10-03T21:37:08.652" v="629" actId="20577"/>
-          <ac:spMkLst>
-            <pc:docMk/>
-            <pc:sldMk cId="0" sldId="267"/>
-            <ac:spMk id="145" creationId="{00000000-0000-0000-0000-000000000000}"/>
-          </ac:spMkLst>
-        </pc:spChg>
-      </pc:sldChg>
-    </pc:docChg>
-  </pc:docChgLst>
-</pc:chgInfo>
 </file>
 
 <file path=ppt/notesMasters/notesMaster1.xml><?xml version="1.0" encoding="utf-8"?>
@@ -1265,7 +1128,213 @@
               </a:spcAft>
               <a:buNone/>
             </a:pPr>
-            <a:endParaRPr/>
+            <a:r>
+              <a:rPr lang="en-US" dirty="0"/>
+              <a:t>Best Practice: Updating State Based on Old State</a:t>
+            </a:r>
+          </a:p>
+          <a:p>
+            <a:pPr marL="0" lvl="0" indent="0" algn="l" rtl="0">
+              <a:spcBef>
+                <a:spcPts val="0"/>
+              </a:spcBef>
+              <a:spcAft>
+                <a:spcPts val="0"/>
+              </a:spcAft>
+              <a:buNone/>
+            </a:pPr>
+            <a:endParaRPr lang="en-US" dirty="0"/>
+          </a:p>
+          <a:p>
+            <a:pPr marL="0" lvl="0" indent="0" algn="l" rtl="0">
+              <a:spcBef>
+                <a:spcPts val="0"/>
+              </a:spcBef>
+              <a:spcAft>
+                <a:spcPts val="0"/>
+              </a:spcAft>
+              <a:buNone/>
+            </a:pPr>
+            <a:r>
+              <a:rPr lang="en-US" dirty="0"/>
+              <a:t>//pass a function to your state updating function</a:t>
+            </a:r>
+          </a:p>
+          <a:p>
+            <a:pPr marL="0" lvl="0" indent="0" algn="l" rtl="0">
+              <a:spcBef>
+                <a:spcPts val="0"/>
+              </a:spcBef>
+              <a:spcAft>
+                <a:spcPts val="0"/>
+              </a:spcAft>
+              <a:buNone/>
+            </a:pPr>
+            <a:r>
+              <a:rPr lang="en-CA" sz="1100" b="0" i="0" u="none" strike="noStrike" cap="none" dirty="0">
+                <a:solidFill>
+                  <a:srgbClr val="000000"/>
+                </a:solidFill>
+                <a:effectLst/>
+                <a:latin typeface="Arial"/>
+                <a:ea typeface="Arial"/>
+                <a:cs typeface="Arial"/>
+                <a:sym typeface="Arial"/>
+              </a:rPr>
+              <a:t>const </a:t>
+            </a:r>
+            <a:r>
+              <a:rPr lang="en-CA" sz="1100" b="0" i="0" u="none" strike="noStrike" cap="none" dirty="0" err="1">
+                <a:solidFill>
+                  <a:srgbClr val="000000"/>
+                </a:solidFill>
+                <a:effectLst/>
+                <a:latin typeface="Arial"/>
+                <a:ea typeface="Arial"/>
+                <a:cs typeface="Arial"/>
+                <a:sym typeface="Arial"/>
+              </a:rPr>
+              <a:t>toggleMessage</a:t>
+            </a:r>
+            <a:r>
+              <a:rPr lang="en-CA" sz="1100" b="0" i="0" u="none" strike="noStrike" cap="none" dirty="0">
+                <a:solidFill>
+                  <a:srgbClr val="000000"/>
+                </a:solidFill>
+                <a:effectLst/>
+                <a:latin typeface="Arial"/>
+                <a:ea typeface="Arial"/>
+                <a:cs typeface="Arial"/>
+                <a:sym typeface="Arial"/>
+              </a:rPr>
+              <a:t> = (event) =&gt; {</a:t>
+            </a:r>
+          </a:p>
+          <a:p>
+            <a:pPr marL="158750" indent="0">
+              <a:buNone/>
+            </a:pPr>
+            <a:r>
+              <a:rPr lang="en-CA" sz="1100" b="0" i="0" u="none" strike="noStrike" cap="none" dirty="0">
+                <a:solidFill>
+                  <a:srgbClr val="000000"/>
+                </a:solidFill>
+                <a:effectLst/>
+                <a:latin typeface="Arial"/>
+                <a:ea typeface="Arial"/>
+                <a:cs typeface="Arial"/>
+                <a:sym typeface="Arial"/>
+              </a:rPr>
+              <a:t>    </a:t>
+            </a:r>
+            <a:r>
+              <a:rPr lang="en-CA" sz="1100" b="0" i="0" u="none" strike="noStrike" cap="none" dirty="0" err="1">
+                <a:solidFill>
+                  <a:srgbClr val="000000"/>
+                </a:solidFill>
+                <a:effectLst/>
+                <a:latin typeface="Arial"/>
+                <a:ea typeface="Arial"/>
+                <a:cs typeface="Arial"/>
+                <a:sym typeface="Arial"/>
+              </a:rPr>
+              <a:t>setHideMessage</a:t>
+            </a:r>
+            <a:r>
+              <a:rPr lang="en-CA" sz="1100" b="0" i="0" u="none" strike="noStrike" cap="none" dirty="0">
+                <a:solidFill>
+                  <a:srgbClr val="000000"/>
+                </a:solidFill>
+                <a:effectLst/>
+                <a:latin typeface="Arial"/>
+                <a:ea typeface="Arial"/>
+                <a:cs typeface="Arial"/>
+                <a:sym typeface="Arial"/>
+              </a:rPr>
+              <a:t>(</a:t>
+            </a:r>
+            <a:r>
+              <a:rPr lang="en-CA" sz="1100" b="0" i="0" u="none" strike="noStrike" cap="none" dirty="0" err="1">
+                <a:solidFill>
+                  <a:srgbClr val="000000"/>
+                </a:solidFill>
+                <a:effectLst/>
+                <a:latin typeface="Arial"/>
+                <a:ea typeface="Arial"/>
+                <a:cs typeface="Arial"/>
+                <a:sym typeface="Arial"/>
+              </a:rPr>
+              <a:t>wasHidden</a:t>
+            </a:r>
+            <a:r>
+              <a:rPr lang="en-CA" sz="1100" b="0" i="0" u="none" strike="noStrike" cap="none" dirty="0">
+                <a:solidFill>
+                  <a:srgbClr val="000000"/>
+                </a:solidFill>
+                <a:effectLst/>
+                <a:latin typeface="Arial"/>
+                <a:ea typeface="Arial"/>
+                <a:cs typeface="Arial"/>
+                <a:sym typeface="Arial"/>
+              </a:rPr>
+              <a:t> =&gt; !</a:t>
+            </a:r>
+            <a:r>
+              <a:rPr lang="en-CA" sz="1100" b="0" i="0" u="none" strike="noStrike" cap="none" dirty="0" err="1">
+                <a:solidFill>
+                  <a:srgbClr val="000000"/>
+                </a:solidFill>
+                <a:effectLst/>
+                <a:latin typeface="Arial"/>
+                <a:ea typeface="Arial"/>
+                <a:cs typeface="Arial"/>
+                <a:sym typeface="Arial"/>
+              </a:rPr>
+              <a:t>wasHidden</a:t>
+            </a:r>
+            <a:r>
+              <a:rPr lang="en-CA" sz="1100" b="0" i="0" u="none" strike="noStrike" cap="none" dirty="0">
+                <a:solidFill>
+                  <a:srgbClr val="000000"/>
+                </a:solidFill>
+                <a:effectLst/>
+                <a:latin typeface="Arial"/>
+                <a:ea typeface="Arial"/>
+                <a:cs typeface="Arial"/>
+                <a:sym typeface="Arial"/>
+              </a:rPr>
+              <a:t>);</a:t>
+            </a:r>
+          </a:p>
+          <a:p>
+            <a:pPr marL="158750" indent="0">
+              <a:buNone/>
+            </a:pPr>
+            <a:r>
+              <a:rPr lang="en-CA" sz="1100" b="0" i="0" u="none" strike="noStrike" cap="none" dirty="0">
+                <a:solidFill>
+                  <a:srgbClr val="000000"/>
+                </a:solidFill>
+                <a:effectLst/>
+                <a:latin typeface="Arial"/>
+                <a:ea typeface="Arial"/>
+                <a:cs typeface="Arial"/>
+                <a:sym typeface="Arial"/>
+              </a:rPr>
+              <a:t>}</a:t>
+            </a:r>
+          </a:p>
+          <a:p>
+            <a:pPr marL="0" lvl="0" indent="0" algn="l" rtl="0">
+              <a:spcBef>
+                <a:spcPts val="0"/>
+              </a:spcBef>
+              <a:spcAft>
+                <a:spcPts val="0"/>
+              </a:spcAft>
+              <a:buNone/>
+            </a:pPr>
+            <a:endParaRPr dirty="0"/>
           </a:p>
         </p:txBody>
       </p:sp>
@@ -12712,16 +12781,7 @@
                 </a:solidFill>
                 <a:hlinkClick r:id="rId3"/>
               </a:rPr>
-              <a:t>Example 1</a:t>
-            </a:r>
-            <a:r>
-              <a:rPr lang="en" sz="1400" u="sng">
-                <a:solidFill>
-                  <a:schemeClr val="hlink"/>
-                </a:solidFill>
-                <a:hlinkClick r:id="rId3"/>
-              </a:rPr>
-              <a:t>: Listening to Keys</a:t>
+              <a:t>Example 1: Listening to Keys</a:t>
             </a:r>
             <a:br>
               <a:rPr lang="en" sz="1400" u="sng">

</xml_diff>